<commit_message>
Flowchart: primary-reserve evaluation and existence condition (6)
Co-Authored-By: Claude Opus 5.5 <noreply@anthropic.com>
</commit_message>
<xml_diff>
--- a/revision_r1/figures/flowchart.pptx
+++ b/revision_r1/figures/flowchart.pptx
@@ -4591,16 +4591,19 @@
                 </a:solidFill>
                 <a:latin typeface="Times New Roman"/>
               </a:rPr>
-              <a:t>existence condition hΣ &lt; ΔP</a:t>
-            </a:r>
-            <a:r>
-              <a:rPr sz="730" b="0" baseline="-25000">
+              <a:t>existence condition (6),</a:t>
+            </a:r>
+          </a:p>
+          <a:p>
+            <a:pPr algn="ctr"/>
+            <a:r>
+              <a:rPr sz="730" b="0">
                 <a:solidFill>
                   <a:srgbClr val="000000"/>
                 </a:solidFill>
                 <a:latin typeface="Times New Roman"/>
               </a:rPr>
-              <a:t>L</a:t>
+              <a:t>checked against detected</a:t>
             </a:r>
           </a:p>
           <a:p>
@@ -4612,19 +4615,7 @@
                 </a:solidFill>
                 <a:latin typeface="Times New Roman"/>
               </a:rPr>
-              <a:t>&lt; hΣ + M, checked against</a:t>
-            </a:r>
-          </a:p>
-          <a:p>
-            <a:pPr algn="ctr"/>
-            <a:r>
-              <a:rPr sz="730" b="0">
-                <a:solidFill>
-                  <a:srgbClr val="000000"/>
-                </a:solidFill>
-                <a:latin typeface="Times New Roman"/>
-              </a:rPr>
-              <a:t>detected cycles (Figure 7)</a:t>
+              <a:t>cycles (Figure 7)</a:t>
             </a:r>
           </a:p>
         </p:txBody>
@@ -5177,7 +5168,7 @@
                 </a:solidFill>
                 <a:latin typeface="Times New Roman"/>
               </a:rPr>
-              <a:t>FFR, primary-reserve map, ablation of α and of</a:t>
+              <a:t>FFR, primary reserve (map and S3–S4 runs),</a:t>
             </a:r>
           </a:p>
           <a:p>
@@ -5189,7 +5180,7 @@
                 </a:solidFill>
                 <a:latin typeface="Times New Roman"/>
               </a:rPr>
-              <a:t>the gate, SOC near its limits, inertia sweep,</a:t>
+              <a:t>ablation of α and of the gate, SOC near its</a:t>
             </a:r>
           </a:p>
           <a:p>
@@ -5201,7 +5192,7 @@
                 </a:solidFill>
                 <a:latin typeface="Times New Roman"/>
               </a:rPr>
-              <a:t>load rejection (S6)</a:t>
+              <a:t>limits, inertia sweep, load rejection (S6)</a:t>
             </a:r>
           </a:p>
         </p:txBody>

</xml_diff>

<commit_message>
README: map code scenario names to the renumbered scenarios of the paper; updated flowchart
Co-Authored-By: Claude Opus 5.5 <noreply@anthropic.com>
</commit_message>
<xml_diff>
--- a/revision_r1/figures/flowchart.pptx
+++ b/revision_r1/figures/flowchart.pptx
@@ -3193,7 +3193,7 @@
                 </a:solidFill>
                 <a:latin typeface="Times New Roman"/>
               </a:rPr>
-              <a:t>Input: plant and grid parameters,</a:t>
+              <a:t>Input: plant and grid parameters (Table 2),</a:t>
             </a:r>
           </a:p>
           <a:p>
@@ -3205,7 +3205,7 @@
                 </a:solidFill>
                 <a:latin typeface="Times New Roman"/>
               </a:rPr>
-              <a:t>scenarios S1–S5 (Table 2)</a:t>
+              <a:t>scenarios S1–S4 (Section 3.5)</a:t>
             </a:r>
           </a:p>
         </p:txBody>
@@ -3588,7 +3588,7 @@
                 </a:solidFill>
                 <a:latin typeface="Times New Roman"/>
               </a:rPr>
-              <a:t>Scenario evaluation: S1–S5 × five controllers</a:t>
+              <a:t>Scenario evaluation: S1–S4 × five controllers</a:t>
             </a:r>
           </a:p>
           <a:p>
@@ -5168,7 +5168,7 @@
                 </a:solidFill>
                 <a:latin typeface="Times New Roman"/>
               </a:rPr>
-              <a:t>FFR, primary reserve (map and S3–S4 runs),</a:t>
+              <a:t>FFR, primary reserve (map and S2–S3 runs),</a:t>
             </a:r>
           </a:p>
           <a:p>
@@ -5192,7 +5192,7 @@
                 </a:solidFill>
                 <a:latin typeface="Times New Roman"/>
               </a:rPr>
-              <a:t>limits, inertia sweep, load rejection (S6)</a:t>
+              <a:t>limits, inertia sweep, load rejection (S5)</a:t>
             </a:r>
           </a:p>
         </p:txBody>

</xml_diff>